<commit_message>
docs: clarify final prototype workflow
Co-authored-by: Elisha Sam Peter Prabhu <ElishaSamPeterPrabhu@users.noreply.github.com>
</commit_message>
<xml_diff>
--- a/docs/workshop-overview/workshop-overview.pptx
+++ b/docs/workshop-overview/workshop-overview.pptx
@@ -3771,14 +3771,55 @@
       </p:sp>
       <p:sp>
         <p:nvSpPr>
-          <p:cNvPr id="28" name="Shape 26"/>
-          <p:cNvSpPr/>
-          <p:nvPr/>
-        </p:nvSpPr>
-        <p:spPr>
-          <a:xfrm>
-            <a:off x="731520" y="3401568"/>
-            <a:ext cx="1298448" cy="822960"/>
+          <p:cNvPr id="28" name="Text 26"/>
+          <p:cNvSpPr/>
+          <p:nvPr/>
+        </p:nvSpPr>
+        <p:spPr>
+          <a:xfrm>
+            <a:off x="4343400" y="2999232"/>
+            <a:ext cx="3474720" cy="274320"/>
+          </a:xfrm>
+          <a:prstGeom prst="rect">
+            <a:avLst/>
+          </a:prstGeom>
+          <a:noFill/>
+          <a:ln/>
+        </p:spPr>
+        <p:txBody>
+          <a:bodyPr wrap="square" lIns="0" tIns="0" rIns="0" bIns="0" rtlCol="0" anchor="ctr">
+            <a:normAutofit/>
+          </a:bodyPr>
+          <a:lstStyle/>
+          <a:p>
+            <a:pPr algn="ctr" indent="0" marL="0">
+              <a:buNone/>
+            </a:pPr>
+            <a:r>
+              <a:rPr lang="en-US" sz="1100" b="1" spc="130" kern="0" dirty="0">
+                <a:solidFill>
+                  <a:srgbClr val="F47F20"/>
+                </a:solidFill>
+                <a:latin typeface="Arial" pitchFamily="34" charset="0"/>
+                <a:ea typeface="Arial" pitchFamily="34" charset="-122"/>
+                <a:cs typeface="Arial" pitchFamily="34" charset="-120"/>
+              </a:rPr>
+              <a:t>REPEAT AT EVERY STEP</a:t>
+            </a:r>
+            <a:endParaRPr lang="en-US" sz="1100" dirty="0"/>
+          </a:p>
+        </p:txBody>
+      </p:sp>
+      <p:sp>
+        <p:nvSpPr>
+          <p:cNvPr id="29" name="Shape 27"/>
+          <p:cNvSpPr/>
+          <p:nvPr/>
+        </p:nvSpPr>
+        <p:spPr>
+          <a:xfrm>
+            <a:off x="1207008" y="3456432"/>
+            <a:ext cx="1143000" cy="822960"/>
           </a:xfrm>
           <a:prstGeom prst="roundRect">
             <a:avLst>
@@ -3800,14 +3841,14 @@
       </p:sp>
       <p:sp>
         <p:nvSpPr>
-          <p:cNvPr id="29" name="Text 27"/>
-          <p:cNvSpPr/>
-          <p:nvPr/>
-        </p:nvSpPr>
-        <p:spPr>
-          <a:xfrm>
-            <a:off x="896112" y="3520440"/>
-            <a:ext cx="969264" cy="274320"/>
+          <p:cNvPr id="30" name="Text 28"/>
+          <p:cNvSpPr/>
+          <p:nvPr/>
+        </p:nvSpPr>
+        <p:spPr>
+          <a:xfrm>
+            <a:off x="1371600" y="3575304"/>
+            <a:ext cx="813816" cy="274320"/>
           </a:xfrm>
           <a:prstGeom prst="rect">
             <a:avLst/>
@@ -3841,14 +3882,14 @@
       </p:sp>
       <p:sp>
         <p:nvSpPr>
-          <p:cNvPr id="30" name="Text 28"/>
-          <p:cNvSpPr/>
-          <p:nvPr/>
-        </p:nvSpPr>
-        <p:spPr>
-          <a:xfrm>
-            <a:off x="896112" y="3858768"/>
-            <a:ext cx="969264" cy="256032"/>
+          <p:cNvPr id="31" name="Text 29"/>
+          <p:cNvSpPr/>
+          <p:nvPr/>
+        </p:nvSpPr>
+        <p:spPr>
+          <a:xfrm>
+            <a:off x="1371600" y="3913632"/>
+            <a:ext cx="813816" cy="256032"/>
           </a:xfrm>
           <a:prstGeom prst="rect">
             <a:avLst/>
@@ -3882,14 +3923,14 @@
       </p:sp>
       <p:sp>
         <p:nvSpPr>
-          <p:cNvPr id="31" name="Shape 29"/>
-          <p:cNvSpPr/>
-          <p:nvPr/>
-        </p:nvSpPr>
-        <p:spPr>
-          <a:xfrm>
-            <a:off x="2304288" y="3401568"/>
-            <a:ext cx="1298448" cy="822960"/>
+          <p:cNvPr id="32" name="Shape 30"/>
+          <p:cNvSpPr/>
+          <p:nvPr/>
+        </p:nvSpPr>
+        <p:spPr>
+          <a:xfrm>
+            <a:off x="2560320" y="3456432"/>
+            <a:ext cx="1143000" cy="822960"/>
           </a:xfrm>
           <a:prstGeom prst="roundRect">
             <a:avLst>
@@ -3911,14 +3952,14 @@
       </p:sp>
       <p:sp>
         <p:nvSpPr>
-          <p:cNvPr id="32" name="Text 30"/>
-          <p:cNvSpPr/>
-          <p:nvPr/>
-        </p:nvSpPr>
-        <p:spPr>
-          <a:xfrm>
-            <a:off x="2468880" y="3520440"/>
-            <a:ext cx="969264" cy="274320"/>
+          <p:cNvPr id="33" name="Text 31"/>
+          <p:cNvSpPr/>
+          <p:nvPr/>
+        </p:nvSpPr>
+        <p:spPr>
+          <a:xfrm>
+            <a:off x="2724912" y="3575304"/>
+            <a:ext cx="813816" cy="274320"/>
           </a:xfrm>
           <a:prstGeom prst="rect">
             <a:avLst/>
@@ -3952,14 +3993,14 @@
       </p:sp>
       <p:sp>
         <p:nvSpPr>
-          <p:cNvPr id="33" name="Text 31"/>
-          <p:cNvSpPr/>
-          <p:nvPr/>
-        </p:nvSpPr>
-        <p:spPr>
-          <a:xfrm>
-            <a:off x="2468880" y="3858768"/>
-            <a:ext cx="969264" cy="256032"/>
+          <p:cNvPr id="34" name="Text 32"/>
+          <p:cNvSpPr/>
+          <p:nvPr/>
+        </p:nvSpPr>
+        <p:spPr>
+          <a:xfrm>
+            <a:off x="2724912" y="3913632"/>
+            <a:ext cx="813816" cy="256032"/>
           </a:xfrm>
           <a:prstGeom prst="rect">
             <a:avLst/>
@@ -3993,14 +4034,14 @@
       </p:sp>
       <p:sp>
         <p:nvSpPr>
-          <p:cNvPr id="34" name="Shape 32"/>
-          <p:cNvSpPr/>
-          <p:nvPr/>
-        </p:nvSpPr>
-        <p:spPr>
-          <a:xfrm>
-            <a:off x="3877056" y="3401568"/>
-            <a:ext cx="1298448" cy="822960"/>
+          <p:cNvPr id="35" name="Shape 33"/>
+          <p:cNvSpPr/>
+          <p:nvPr/>
+        </p:nvSpPr>
+        <p:spPr>
+          <a:xfrm>
+            <a:off x="3913632" y="3456432"/>
+            <a:ext cx="1143000" cy="822960"/>
           </a:xfrm>
           <a:prstGeom prst="roundRect">
             <a:avLst>
@@ -4022,14 +4063,14 @@
       </p:sp>
       <p:sp>
         <p:nvSpPr>
-          <p:cNvPr id="35" name="Text 33"/>
-          <p:cNvSpPr/>
-          <p:nvPr/>
-        </p:nvSpPr>
-        <p:spPr>
-          <a:xfrm>
-            <a:off x="4041648" y="3520440"/>
-            <a:ext cx="969264" cy="274320"/>
+          <p:cNvPr id="36" name="Text 34"/>
+          <p:cNvSpPr/>
+          <p:nvPr/>
+        </p:nvSpPr>
+        <p:spPr>
+          <a:xfrm>
+            <a:off x="4078224" y="3575304"/>
+            <a:ext cx="813816" cy="274320"/>
           </a:xfrm>
           <a:prstGeom prst="rect">
             <a:avLst/>
@@ -4063,14 +4104,14 @@
       </p:sp>
       <p:sp>
         <p:nvSpPr>
-          <p:cNvPr id="36" name="Text 34"/>
-          <p:cNvSpPr/>
-          <p:nvPr/>
-        </p:nvSpPr>
-        <p:spPr>
-          <a:xfrm>
-            <a:off x="4041648" y="3858768"/>
-            <a:ext cx="969264" cy="256032"/>
+          <p:cNvPr id="37" name="Text 35"/>
+          <p:cNvSpPr/>
+          <p:nvPr/>
+        </p:nvSpPr>
+        <p:spPr>
+          <a:xfrm>
+            <a:off x="4078224" y="3913632"/>
+            <a:ext cx="813816" cy="256032"/>
           </a:xfrm>
           <a:prstGeom prst="rect">
             <a:avLst/>
@@ -4104,14 +4145,14 @@
       </p:sp>
       <p:sp>
         <p:nvSpPr>
-          <p:cNvPr id="37" name="Shape 35"/>
-          <p:cNvSpPr/>
-          <p:nvPr/>
-        </p:nvSpPr>
-        <p:spPr>
-          <a:xfrm>
-            <a:off x="5449824" y="3401568"/>
-            <a:ext cx="1298448" cy="822960"/>
+          <p:cNvPr id="38" name="Shape 36"/>
+          <p:cNvSpPr/>
+          <p:nvPr/>
+        </p:nvSpPr>
+        <p:spPr>
+          <a:xfrm>
+            <a:off x="5266944" y="3456432"/>
+            <a:ext cx="1143000" cy="822960"/>
           </a:xfrm>
           <a:prstGeom prst="roundRect">
             <a:avLst>
@@ -4133,14 +4174,14 @@
       </p:sp>
       <p:sp>
         <p:nvSpPr>
-          <p:cNvPr id="38" name="Text 36"/>
-          <p:cNvSpPr/>
-          <p:nvPr/>
-        </p:nvSpPr>
-        <p:spPr>
-          <a:xfrm>
-            <a:off x="5614416" y="3520440"/>
-            <a:ext cx="969264" cy="274320"/>
+          <p:cNvPr id="39" name="Text 37"/>
+          <p:cNvSpPr/>
+          <p:nvPr/>
+        </p:nvSpPr>
+        <p:spPr>
+          <a:xfrm>
+            <a:off x="5431536" y="3575304"/>
+            <a:ext cx="813816" cy="274320"/>
           </a:xfrm>
           <a:prstGeom prst="rect">
             <a:avLst/>
@@ -4174,14 +4215,14 @@
       </p:sp>
       <p:sp>
         <p:nvSpPr>
-          <p:cNvPr id="39" name="Text 37"/>
-          <p:cNvSpPr/>
-          <p:nvPr/>
-        </p:nvSpPr>
-        <p:spPr>
-          <a:xfrm>
-            <a:off x="5614416" y="3858768"/>
-            <a:ext cx="969264" cy="256032"/>
+          <p:cNvPr id="40" name="Text 38"/>
+          <p:cNvSpPr/>
+          <p:nvPr/>
+        </p:nvSpPr>
+        <p:spPr>
+          <a:xfrm>
+            <a:off x="5431536" y="3913632"/>
+            <a:ext cx="813816" cy="256032"/>
           </a:xfrm>
           <a:prstGeom prst="rect">
             <a:avLst/>
@@ -4215,14 +4256,14 @@
       </p:sp>
       <p:sp>
         <p:nvSpPr>
-          <p:cNvPr id="40" name="Shape 38"/>
-          <p:cNvSpPr/>
-          <p:nvPr/>
-        </p:nvSpPr>
-        <p:spPr>
-          <a:xfrm>
-            <a:off x="7022592" y="3401568"/>
-            <a:ext cx="1298448" cy="822960"/>
+          <p:cNvPr id="41" name="Shape 39"/>
+          <p:cNvSpPr/>
+          <p:nvPr/>
+        </p:nvSpPr>
+        <p:spPr>
+          <a:xfrm>
+            <a:off x="6620256" y="3456432"/>
+            <a:ext cx="1143000" cy="822960"/>
           </a:xfrm>
           <a:prstGeom prst="roundRect">
             <a:avLst>
@@ -4244,14 +4285,14 @@
       </p:sp>
       <p:sp>
         <p:nvSpPr>
-          <p:cNvPr id="41" name="Text 39"/>
-          <p:cNvSpPr/>
-          <p:nvPr/>
-        </p:nvSpPr>
-        <p:spPr>
-          <a:xfrm>
-            <a:off x="7187184" y="3520440"/>
-            <a:ext cx="969264" cy="274320"/>
+          <p:cNvPr id="42" name="Text 40"/>
+          <p:cNvSpPr/>
+          <p:nvPr/>
+        </p:nvSpPr>
+        <p:spPr>
+          <a:xfrm>
+            <a:off x="6784848" y="3575304"/>
+            <a:ext cx="813816" cy="274320"/>
           </a:xfrm>
           <a:prstGeom prst="rect">
             <a:avLst/>
@@ -4285,14 +4326,14 @@
       </p:sp>
       <p:sp>
         <p:nvSpPr>
-          <p:cNvPr id="42" name="Text 40"/>
-          <p:cNvSpPr/>
-          <p:nvPr/>
-        </p:nvSpPr>
-        <p:spPr>
-          <a:xfrm>
-            <a:off x="7187184" y="3858768"/>
-            <a:ext cx="969264" cy="256032"/>
+          <p:cNvPr id="43" name="Text 41"/>
+          <p:cNvSpPr/>
+          <p:nvPr/>
+        </p:nvSpPr>
+        <p:spPr>
+          <a:xfrm>
+            <a:off x="6784848" y="3913632"/>
+            <a:ext cx="813816" cy="256032"/>
           </a:xfrm>
           <a:prstGeom prst="rect">
             <a:avLst/>
@@ -4326,14 +4367,14 @@
       </p:sp>
       <p:sp>
         <p:nvSpPr>
-          <p:cNvPr id="43" name="Shape 41"/>
-          <p:cNvSpPr/>
-          <p:nvPr/>
-        </p:nvSpPr>
-        <p:spPr>
-          <a:xfrm>
-            <a:off x="8595360" y="3401568"/>
-            <a:ext cx="1298448" cy="822960"/>
+          <p:cNvPr id="44" name="Shape 42"/>
+          <p:cNvSpPr/>
+          <p:nvPr/>
+        </p:nvSpPr>
+        <p:spPr>
+          <a:xfrm>
+            <a:off x="7973568" y="3456432"/>
+            <a:ext cx="1143000" cy="822960"/>
           </a:xfrm>
           <a:prstGeom prst="roundRect">
             <a:avLst>
@@ -4355,14 +4396,14 @@
       </p:sp>
       <p:sp>
         <p:nvSpPr>
-          <p:cNvPr id="44" name="Text 42"/>
-          <p:cNvSpPr/>
-          <p:nvPr/>
-        </p:nvSpPr>
-        <p:spPr>
-          <a:xfrm>
-            <a:off x="8759952" y="3520440"/>
-            <a:ext cx="969264" cy="274320"/>
+          <p:cNvPr id="45" name="Text 43"/>
+          <p:cNvSpPr/>
+          <p:nvPr/>
+        </p:nvSpPr>
+        <p:spPr>
+          <a:xfrm>
+            <a:off x="8138160" y="3575304"/>
+            <a:ext cx="813816" cy="274320"/>
           </a:xfrm>
           <a:prstGeom prst="rect">
             <a:avLst/>
@@ -4396,14 +4437,14 @@
       </p:sp>
       <p:sp>
         <p:nvSpPr>
-          <p:cNvPr id="45" name="Text 43"/>
-          <p:cNvSpPr/>
-          <p:nvPr/>
-        </p:nvSpPr>
-        <p:spPr>
-          <a:xfrm>
-            <a:off x="8759952" y="3858768"/>
-            <a:ext cx="969264" cy="256032"/>
+          <p:cNvPr id="46" name="Text 44"/>
+          <p:cNvSpPr/>
+          <p:nvPr/>
+        </p:nvSpPr>
+        <p:spPr>
+          <a:xfrm>
+            <a:off x="8138160" y="3913632"/>
+            <a:ext cx="813816" cy="256032"/>
           </a:xfrm>
           <a:prstGeom prst="rect">
             <a:avLst/>
@@ -4437,14 +4478,14 @@
       </p:sp>
       <p:sp>
         <p:nvSpPr>
-          <p:cNvPr id="46" name="Shape 44"/>
-          <p:cNvSpPr/>
-          <p:nvPr/>
-        </p:nvSpPr>
-        <p:spPr>
-          <a:xfrm>
-            <a:off x="10168128" y="3401568"/>
-            <a:ext cx="1298448" cy="822960"/>
+          <p:cNvPr id="47" name="Shape 45"/>
+          <p:cNvSpPr/>
+          <p:nvPr/>
+        </p:nvSpPr>
+        <p:spPr>
+          <a:xfrm>
+            <a:off x="9326880" y="3456432"/>
+            <a:ext cx="1143000" cy="822960"/>
           </a:xfrm>
           <a:prstGeom prst="roundRect">
             <a:avLst>
@@ -4466,14 +4507,14 @@
       </p:sp>
       <p:sp>
         <p:nvSpPr>
-          <p:cNvPr id="47" name="Text 45"/>
-          <p:cNvSpPr/>
-          <p:nvPr/>
-        </p:nvSpPr>
-        <p:spPr>
-          <a:xfrm>
-            <a:off x="10332720" y="3520440"/>
-            <a:ext cx="969264" cy="274320"/>
+          <p:cNvPr id="48" name="Text 46"/>
+          <p:cNvSpPr/>
+          <p:nvPr/>
+        </p:nvSpPr>
+        <p:spPr>
+          <a:xfrm>
+            <a:off x="9491472" y="3575304"/>
+            <a:ext cx="813816" cy="274320"/>
           </a:xfrm>
           <a:prstGeom prst="rect">
             <a:avLst/>
@@ -4507,14 +4548,14 @@
       </p:sp>
       <p:sp>
         <p:nvSpPr>
-          <p:cNvPr id="48" name="Text 46"/>
-          <p:cNvSpPr/>
-          <p:nvPr/>
-        </p:nvSpPr>
-        <p:spPr>
-          <a:xfrm>
-            <a:off x="10332720" y="3858768"/>
-            <a:ext cx="969264" cy="256032"/>
+          <p:cNvPr id="49" name="Text 47"/>
+          <p:cNvSpPr/>
+          <p:nvPr/>
+        </p:nvSpPr>
+        <p:spPr>
+          <a:xfrm>
+            <a:off x="9491472" y="3913632"/>
+            <a:ext cx="813816" cy="256032"/>
           </a:xfrm>
           <a:prstGeom prst="rect">
             <a:avLst/>
@@ -4548,7 +4589,7 @@
       </p:sp>
       <p:sp>
         <p:nvSpPr>
-          <p:cNvPr id="49" name="Text 47"/>
+          <p:cNvPr id="50" name="Text 48"/>
           <p:cNvSpPr/>
           <p:nvPr/>
         </p:nvSpPr>
@@ -4589,7 +4630,7 @@
       </p:sp>
       <p:sp>
         <p:nvSpPr>
-          <p:cNvPr id="50" name="Shape 48"/>
+          <p:cNvPr id="51" name="Shape 49"/>
           <p:cNvSpPr/>
           <p:nvPr/>
         </p:nvSpPr>
@@ -4618,7 +4659,7 @@
       </p:sp>
       <p:sp>
         <p:nvSpPr>
-          <p:cNvPr id="51" name="Text 49"/>
+          <p:cNvPr id="52" name="Text 50"/>
           <p:cNvSpPr/>
           <p:nvPr/>
         </p:nvSpPr>

</xml_diff>